<commit_message>
chore(p07): perkuat penanganan galat 4-status UI dan data source ganda pada pertemuan 07
</commit_message>
<xml_diff>
--- a/03_slide_presentasi/PERTEMUAN_07_Clean_Architecture_dan_Design_Pattern.pptx
+++ b/03_slide_presentasi/PERTEMUAN_07_Clean_Architecture_dan_Design_Pattern.pptx
@@ -11461,7 +11461,7 @@
               </a:defRPr>
             </a:pPr>
             <a:r>
-              <a:t>✔  Tampilkan daftar produk secara reaktif menggunakan BlocBuilder dan floating action button untuk refresh data!</a:t>
+              <a:t>✔  Terapkan 4 Status UI (Initial, Loading, Loaded, Error) secara reaktif dengan tombol muat ulang dan simulasi error server!</a:t>
             </a:r>
           </a:p>
           <a:p>
@@ -11477,7 +11477,7 @@
               </a:defRPr>
             </a:pPr>
             <a:r>
-              <a:t>✔  Target Pengujian: Jalankan di browser Chrome ('flutter run -d chrome') dan buktikan bahwa pemanggilan data terisolasi rapi!</a:t>
+              <a:t>✔  Target Pengujian: Jalankan di browser Chrome ('flutter run -d chrome') dan buktikan seluruh alur terisolasi rapi!</a:t>
             </a:r>
           </a:p>
         </p:txBody>

</xml_diff>